<commit_message>
Trend Micro proposal: position Apex One as a Nessus replacement
Co-Authored-By: Claude Opus 5.5 <noreply@anthropic.com>
Claude-Session: https://claude.ai/code/session_01AC58wvp3ibSdWMcWgRepkj
</commit_message>
<xml_diff>
--- a/ENG._Nessus_vs_Trend_Micro_Apex_One_Proposal_for_Westin_Resort_Guam_SECUKOREA.pptx
+++ b/ENG._Nessus_vs_Trend_Micro_Apex_One_Proposal_for_Westin_Resort_Guam_SECUKOREA.pptx
@@ -520,7 +520,7 @@
           <a:p>
             <a:r>
               <a:rPr lang="en-US" dirty="0"/>
-              <a:t>Title slide. This proposal compares the resort's current tool, Nessus, with Trend Micro Apex One and recommends adding automatic endpoint protection with virtual patching.</a:t>
+              <a:t>Title slide. This proposal compares the resort’s current tool, Nessus, with Trend Micro Apex One and recommends replacing Nessus with Apex One: vulnerability assessment plus automatic protection and virtual patching in one agent.</a:t>
             </a:r>
             <a:endParaRPr lang="en-US" dirty="0"/>
           </a:p>
@@ -784,7 +784,7 @@
           <a:p>
             <a:r>
               <a:rPr lang="en-US" dirty="0"/>
-              <a:t>Detection and response for a lean IT team: Apex One detects and stops attacks by behavior, isolates infected endpoints, and gives one console for investigation. SECUKOREA engineers support the resort around the clock.</a:t>
+              <a:t>Detection and response for a small IT team: Apex One detects and stops attacks by behavior, isolates infected endpoints, and gives one console for investigation. SECUKOREA engineers support the resort around the clock.</a:t>
             </a:r>
             <a:endParaRPr lang="en-US" dirty="0"/>
           </a:p>
@@ -960,7 +960,7 @@
           <a:p>
             <a:r>
               <a:rPr lang="en-US" dirty="0"/>
-              <a:t>Side-by-side summary. Nessus remains strong at periodic discovery; Apex One adds protection, virtual patching, POS lockdown and data protection with lower day-to-day workload.</a:t>
+              <a:t>Side-by-side summary. Apex One covers what Nessus does on endpoints — vulnerability assessment — and adds protection, virtual patching, POS lockdown and data protection, with lower day-to-day workload.</a:t>
             </a:r>
             <a:endParaRPr lang="en-US" dirty="0"/>
           </a:p>
@@ -1136,7 +1136,7 @@
           <a:p>
             <a:r>
               <a:rPr lang="en-US" dirty="0"/>
-              <a:t>Nessus and Apex One work well together: Nessus finds, Apex One shields and protects. Apex One is added to every endpoint without changing existing Nessus processes, and SECUKOREA supports the resort 24/7.</a:t>
+              <a:t>Recommendation: replace Nessus with Apex One. Apex One is deployed first and its vulnerability assessments are verified; Nessus is then retired, so there is never a gap in visibility. SECUKOREA supports the resort 24/7.</a:t>
             </a:r>
             <a:endParaRPr lang="en-US" dirty="0"/>
           </a:p>
@@ -1312,7 +1312,7 @@
           <a:p>
             <a:r>
               <a:rPr lang="en-US" dirty="0"/>
-              <a:t>Key message: Nessus tells us where the gaps are; Apex One closes them automatically, including virtual patches for vulnerabilities that cannot be patched right away.</a:t>
+              <a:t>Key message: Nessus only tells us where the gaps are. Apex One replaces it — it assesses vulnerabilities and also closes them automatically, including virtual patches for systems that cannot be patched right away.</a:t>
             </a:r>
             <a:endParaRPr lang="en-US" dirty="0"/>
           </a:p>
@@ -1576,7 +1576,7 @@
           <a:p>
             <a:r>
               <a:rPr lang="en-US" dirty="0"/>
-              <a:t>Set the scene: a 24/7 resort with a lean IT team, payment terminals and some older systems. Nessus is useful, but it only produces findings.</a:t>
+              <a:t>Set the scene: a 24/7 resort with a small IT team, payment terminals and some older systems. Nessus only produces findings; the resort needs a tool that also protects.</a:t>
             </a:r>
             <a:endParaRPr lang="en-US" dirty="0"/>
           </a:p>
@@ -1752,7 +1752,7 @@
           <a:p>
             <a:r>
               <a:rPr lang="en-US" dirty="0"/>
-              <a:t>Analogy for non-technical stakeholders: Nessus is the inspector who lists broken locks. Apex One posts a guard at every door, fits a temporary lock right away, and can undo ransomware damage.</a:t>
+              <a:t>Analogy for non-technical stakeholders: Nessus is the inspector who lists broken locks. Apex One replaces the inspector — it finds the broken locks too, posts a guard at every door, fits a temporary lock right away, and can undo ransomware damage.</a:t>
             </a:r>
             <a:endParaRPr lang="en-US" dirty="0"/>
           </a:p>
@@ -2104,7 +2104,7 @@
           <a:p>
             <a:r>
               <a:rPr lang="en-US" dirty="0"/>
-              <a:t>This is where Nessus and Apex One work together: Nessus finds the CVE, Apex One shields it the same day, and IT installs the permanent patch in a planned window. Especially valuable for legacy systems that may never get a patch.</a:t>
+              <a:t>Apex One replaces the scanner and goes further: it finds the CVE, shields it the same day with a virtual patch, and IT installs the permanent patch in a planned window. Especially valuable for legacy systems that may never get a patch.</a:t>
             </a:r>
             <a:endParaRPr lang="en-US" dirty="0"/>
           </a:p>
@@ -7925,7 +7925,7 @@
                 <a:ea typeface="Calibri" pitchFamily="34" charset="-122"/>
                 <a:cs typeface="Calibri" pitchFamily="34" charset="-120"/>
               </a:rPr>
-              <a:t>For a lean IT team: </a:t>
+              <a:t>For a small IT team: </a:t>
             </a:r>
             <a:pPr indent="0" marL="0">
               <a:buNone/>
@@ -11054,7 +11054,7 @@
                           <a:ea typeface="Calibri" pitchFamily="34" charset="-122"/>
                           <a:cs typeface="Calibri" pitchFamily="34" charset="-120"/>
                         </a:rPr>
-                        <a:t>Virtual patching</a:t>
+                        <a:t>Assessed and shielded</a:t>
                       </a:r>
                       <a:pPr indent="0" marL="0">
                         <a:buNone/>
@@ -11068,7 +11068,7 @@
                           <a:ea typeface="Calibri" pitchFamily="34" charset="-122"/>
                           <a:cs typeface="Calibri" pitchFamily="34" charset="-120"/>
                         </a:rPr>
-                        <a:t>  — shielded before the patch is installed</a:t>
+                        <a:t>  — virtual patches before the fix is installed</a:t>
                       </a:r>
                       <a:endParaRPr lang="en-US" sz="1150" dirty="0">
                         <a:latin typeface="Calibri" charset="0"/>
@@ -13838,7 +13838,7 @@
                 <a:ea typeface="Arial" pitchFamily="34" charset="-122"/>
                 <a:cs typeface="Arial" pitchFamily="34" charset="-120"/>
               </a:rPr>
-              <a:t>Find with Nessus, Shield with Apex One</a:t>
+              <a:t>Recommendation: Replace Nessus with Apex One</a:t>
             </a:r>
             <a:endParaRPr lang="en-US" sz="2800" dirty="0"/>
           </a:p>
@@ -14853,7 +14853,7 @@
                 <a:ea typeface="Calibri" pitchFamily="34" charset="-122"/>
                 <a:cs typeface="Calibri" pitchFamily="34" charset="-120"/>
               </a:rPr>
-              <a:t>Nessus (existing)</a:t>
+              <a:t>Nessus (to be retired)</a:t>
             </a:r>
             <a:endParaRPr lang="en-US" sz="1250" dirty="0"/>
           </a:p>
@@ -14870,7 +14870,7 @@
                 <a:ea typeface="Calibri" pitchFamily="34" charset="-122"/>
                 <a:cs typeface="Calibri" pitchFamily="34" charset="-120"/>
               </a:rPr>
-              <a:t>Periodic vulnerability scans; findings are shielded by Apex One virtual patching</a:t>
+              <a:t>Vulnerability assessment moves into the Apex One agent — no separate scanner or scan schedules</a:t>
             </a:r>
             <a:endParaRPr lang="en-US" sz="1250" dirty="0"/>
           </a:p>
@@ -15107,7 +15107,7 @@
                 <a:ea typeface="Arial" pitchFamily="34" charset="-122"/>
                 <a:cs typeface="Arial" pitchFamily="34" charset="-120"/>
               </a:rPr>
-              <a:t>Apex One on Every Endpoint</a:t>
+              <a:t>One Agent Replaces Nessus</a:t>
             </a:r>
             <a:endParaRPr lang="en-US" sz="1700" dirty="0"/>
           </a:p>
@@ -15146,7 +15146,7 @@
                 <a:ea typeface="Calibri" pitchFamily="34" charset="-122"/>
                 <a:cs typeface="Calibri" pitchFamily="34" charset="-120"/>
               </a:rPr>
-              <a:t>Deploy Apex One on all endpoints. Keep Nessus for periodic scans and use its findings to confirm that virtual patches cover critical CVEs.</a:t>
+              <a:t>Deploy Apex One on all endpoints and retire Nessus. Vulnerability assessment, protection and response run from one agent and one console.</a:t>
             </a:r>
             <a:endParaRPr lang="en-US" sz="1100" dirty="0"/>
           </a:p>
@@ -15199,7 +15199,7 @@
                 <a:ea typeface="Calibri" pitchFamily="34" charset="-122"/>
                 <a:cs typeface="Calibri" pitchFamily="34" charset="-120"/>
               </a:rPr>
-              <a:t>Immediate protection; no change to existing processes.</a:t>
+              <a:t>One tool instead of two; protection from day one.</a:t>
             </a:r>
             <a:endParaRPr lang="en-US" sz="1050" dirty="0"/>
           </a:p>
@@ -15265,7 +15265,7 @@
                 <a:ea typeface="Calibri" pitchFamily="34" charset="-122"/>
                 <a:cs typeface="Calibri" pitchFamily="34" charset="-120"/>
               </a:rPr>
-              <a:t>WHAT STAYS THE SAME</a:t>
+              <a:t>HOW THE SWITCH WORKS</a:t>
             </a:r>
             <a:endParaRPr lang="en-US" sz="1000" dirty="0"/>
           </a:p>
@@ -15304,7 +15304,7 @@
                 <a:ea typeface="Arial" pitchFamily="34" charset="-122"/>
                 <a:cs typeface="Arial" pitchFamily="34" charset="-120"/>
               </a:rPr>
-              <a:t>Nessus Keeps Its Role</a:t>
+              <a:t>A Smooth Replacement</a:t>
             </a:r>
             <a:endParaRPr lang="en-US" sz="1700" dirty="0"/>
           </a:p>
@@ -15343,7 +15343,7 @@
                 <a:ea typeface="Calibri" pitchFamily="34" charset="-122"/>
                 <a:cs typeface="Calibri" pitchFamily="34" charset="-120"/>
               </a:rPr>
-              <a:t>Existing Nessus scans and audit processes continue unchanged. Nessus finds the CVEs; Apex One shields them. Nothing is removed or replaced.</a:t>
+              <a:t>Apex One is deployed and verified first. Nessus is retired once Apex One assessments cover every endpoint — no gap in visibility during the switch.</a:t>
             </a:r>
             <a:endParaRPr lang="en-US" sz="1100" dirty="0"/>
           </a:p>
@@ -15396,7 +15396,7 @@
                 <a:ea typeface="Calibri" pitchFamily="34" charset="-122"/>
                 <a:cs typeface="Calibri" pitchFamily="34" charset="-120"/>
               </a:rPr>
-              <a:t>Real-time protection added without changing what already works.</a:t>
+              <a:t>No scanner host, credentials or scan schedules to maintain.</a:t>
             </a:r>
             <a:endParaRPr lang="en-US" sz="1050" dirty="0"/>
           </a:p>
@@ -15435,7 +15435,7 @@
                 <a:ea typeface="Calibri" pitchFamily="34" charset="-122"/>
                 <a:cs typeface="Calibri" pitchFamily="34" charset="-120"/>
               </a:rPr>
-              <a:t>Nessus finds the gaps. Apex One closes them. Together, they cover the resort end to end.</a:t>
+              <a:t>Nessus only finds the gaps. Apex One finds them and closes them — in one agent.</a:t>
             </a:r>
             <a:endParaRPr lang="en-US" sz="1100" dirty="0"/>
           </a:p>
@@ -17260,7 +17260,7 @@
                 <a:ea typeface="Arial" pitchFamily="34" charset="-122"/>
                 <a:cs typeface="Arial" pitchFamily="34" charset="-120"/>
               </a:rPr>
-              <a:t>Nessus Finds the Gaps. Apex One Closes Them.</a:t>
+              <a:t>Replace Nessus with One Agent That Also Protects</a:t>
             </a:r>
             <a:endParaRPr lang="en-US" sz="2800" dirty="0"/>
           </a:p>
@@ -17323,7 +17323,7 @@
                 <a:ea typeface="Calibri" pitchFamily="34" charset="-122"/>
                 <a:cs typeface="Calibri" pitchFamily="34" charset="-120"/>
               </a:rPr>
-              <a:t>The Westin Resort Guam already scans for vulnerabilities with Nessus. Apex One adds what scanning cannot: automatic protection against malware and ransomware, virtual patching that shields vulnerabilities before patches are installed, and detection and response — all in one lightweight agent.</a:t>
+              <a:t>The Westin Resort Guam uses Nessus today, but it only reports vulnerabilities. We propose replacing it with Trend Micro Apex One: vulnerability assessment by CVE, plus automatic protection, virtual patching and detection and response — all in one lightweight agent.</a:t>
             </a:r>
             <a:endParaRPr lang="en-US" sz="1400" dirty="0"/>
           </a:p>
@@ -17477,7 +17477,7 @@
                 <a:ea typeface="Arial" pitchFamily="34" charset="-122"/>
                 <a:cs typeface="Arial" pitchFamily="34" charset="-120"/>
               </a:rPr>
-              <a:t>24/7 resort, lean IT team, scan-only security</a:t>
+              <a:t>24/7 resort, small IT team, scan-only security</a:t>
             </a:r>
             <a:endParaRPr lang="en-US" sz="1500" dirty="0"/>
           </a:p>
@@ -17863,7 +17863,7 @@
                 <a:ea typeface="Arial" pitchFamily="34" charset="-122"/>
                 <a:cs typeface="Arial" pitchFamily="34" charset="-120"/>
               </a:rPr>
-              <a:t>Trend Micro Apex One on every endpoint</a:t>
+              <a:t>Replace Nessus with Apex One</a:t>
             </a:r>
             <a:endParaRPr lang="en-US" sz="1500" dirty="0"/>
           </a:p>
@@ -23842,11 +23842,11 @@
             </a:avLst>
           </a:prstGeom>
           <a:solidFill>
-            <a:srgbClr val="5D6B7E"/>
+            <a:srgbClr val="0F8B99"/>
           </a:solidFill>
           <a:ln w="12700">
             <a:solidFill>
-              <a:srgbClr val="5D6B7E"/>
+              <a:srgbClr val="0F8B99"/>
             </a:solidFill>
             <a:prstDash val="solid"/>
           </a:ln>
@@ -24202,7 +24202,7 @@
                 <a:ea typeface="Calibri" pitchFamily="34" charset="-122"/>
                 <a:cs typeface="Calibri" pitchFamily="34" charset="-120"/>
               </a:rPr>
-              <a:t> covers Discover.  </a:t>
+              <a:t> covers only Discover.  </a:t>
             </a:r>
             <a:pPr indent="0" marL="0">
               <a:buNone/>
@@ -24230,7 +24230,7 @@
                 <a:ea typeface="Calibri" pitchFamily="34" charset="-122"/>
                 <a:cs typeface="Calibri" pitchFamily="34" charset="-120"/>
               </a:rPr>
-              <a:t> covers the rest.</a:t>
+              <a:t> covers every stage.</a:t>
             </a:r>
             <a:endParaRPr lang="en-US" sz="1150" dirty="0"/>
           </a:p>
@@ -29435,7 +29435,7 @@
                 <a:ea typeface="Arial" pitchFamily="34" charset="-122"/>
                 <a:cs typeface="Arial" pitchFamily="34" charset="-120"/>
               </a:rPr>
-              <a:t>Nessus finding</a:t>
+              <a:t>Vulnerability found</a:t>
             </a:r>
             <a:endParaRPr lang="en-US" sz="1300" dirty="0"/>
           </a:p>
@@ -29474,7 +29474,7 @@
                 <a:ea typeface="Calibri" pitchFamily="34" charset="-122"/>
                 <a:cs typeface="Calibri" pitchFamily="34" charset="-120"/>
               </a:rPr>
-              <a:t>CVE found on a front-desk PC</a:t>
+              <a:t>Apex One flags a CVE on a front-desk PC</a:t>
             </a:r>
             <a:endParaRPr lang="en-US" sz="1050" dirty="0"/>
           </a:p>
@@ -30572,7 +30572,7 @@
                 <a:ea typeface="Calibri" pitchFamily="34" charset="-122"/>
                 <a:cs typeface="Calibri" pitchFamily="34" charset="-120"/>
               </a:rPr>
-              <a:t>Assessments are organized by CVE and Microsoft bulletin — the same references Nessus reports use</a:t>
+              <a:t>Vulnerability assessment by CVE and Microsoft bulletin — no separate scanner needed</a:t>
             </a:r>
             <a:endParaRPr lang="en-US" sz="1200" dirty="0"/>
           </a:p>

</xml_diff>

<commit_message>
Trend Micro proposal: remove POS content, simplify engineer scope, restyle web protection card
Co-Authored-By: Claude Opus 5.5 <noreply@anthropic.com>
Claude-Session: https://claude.ai/code/session_01AC58wvp3ibSdWMcWgRepkj
</commit_message>
<xml_diff>
--- a/ENG._Nessus_vs_Trend_Micro_Apex_One_Proposal_for_Westin_Resort_Guam_SECUKOREA.pptx
+++ b/ENG._Nessus_vs_Trend_Micro_Apex_One_Proposal_for_Westin_Resort_Guam_SECUKOREA.pptx
@@ -608,7 +608,7 @@
           <a:p>
             <a:r>
               <a:rPr lang="en-US" dirty="0"/>
-              <a:t>Two protections that matter most for a hotel: ransomware is stopped and its damage undone, and POS or front-desk systems can be locked so only approved software ever runs.</a:t>
+              <a:t>Two protections that matter most for a hotel: ransomware is stopped and its damage undone, and front-desk or other critical systems can be locked so only approved software ever runs.</a:t>
             </a:r>
             <a:endParaRPr lang="en-US" dirty="0"/>
           </a:p>
@@ -960,7 +960,7 @@
           <a:p>
             <a:r>
               <a:rPr lang="en-US" dirty="0"/>
-              <a:t>Side-by-side summary. Apex One covers what Nessus does on endpoints — vulnerability assessment — and adds protection, virtual patching, POS lockdown and data protection, with lower day-to-day workload.</a:t>
+              <a:t>Side-by-side summary. Apex One covers what Nessus does on endpoints — vulnerability assessment — and adds protection, virtual patching, application lockdown and data protection, backed by SECUKOREA’s 24/7 support.</a:t>
             </a:r>
             <a:endParaRPr lang="en-US" dirty="0"/>
           </a:p>
@@ -1048,7 +1048,7 @@
           <a:p>
             <a:r>
               <a:rPr lang="en-US" dirty="0"/>
-              <a:t>Trend Micro is an established vendor with 30+ years in security. Customer examples include a quick-service restaurant chain with POS environments, similar to hospitality.</a:t>
+              <a:t>Trend Micro is an established vendor with 30+ years in security. Customer examples include a quick-service restaurant chain — a customer-facing business similar to hospitality.</a:t>
             </a:r>
             <a:endParaRPr lang="en-US" dirty="0"/>
           </a:p>
@@ -1488,7 +1488,7 @@
           <a:p>
             <a:r>
               <a:rPr lang="en-US" dirty="0"/>
-              <a:t>SECUKOREA supports the resort in two simple ways: 24/7 remote technical support built for overseas sites, and a dedicated engineer assigned to The Westin Resort Guam for stable, well-maintained operation.</a:t>
+              <a:t>SECUKOREA supports the resort in two ways: 24/7 remote technical support built for overseas sites, and a dedicated engineer assigned to The Westin Resort Guam as a single point of contact, with escalation to Trend Micro when needed. Our commitment is stable, worry-free security for the resort.</a:t>
             </a:r>
             <a:endParaRPr lang="en-US" dirty="0"/>
           </a:p>
@@ -1576,7 +1576,7 @@
           <a:p>
             <a:r>
               <a:rPr lang="en-US" dirty="0"/>
-              <a:t>Set the scene: a 24/7 resort with a small IT team, payment terminals and some older systems. Nessus only produces findings; the resort needs a tool that also protects.</a:t>
+              <a:t>Set the scene: a 24/7 resort with a small IT team and some older systems. Nessus only produces findings; the resort needs a tool that also protects.</a:t>
             </a:r>
             <a:endParaRPr lang="en-US" dirty="0"/>
           </a:p>
@@ -1928,7 +1928,7 @@
           <a:p>
             <a:r>
               <a:rPr lang="en-US" dirty="0"/>
-              <a:t>Apex One is automated, insightful and connected, delivered as one lightweight agent. It natively covers Windows, Mac, servers and POS terminals. In this proposal it runs on premises: an Apex One server with the Apex Central console, connected to Trend Micro’s Smart Protection Network.</a:t>
+              <a:t>Apex One is automated, insightful and connected, delivered as one lightweight agent. It natively covers Windows PCs, laptops, Mac and servers. In this proposal it runs on premises: an Apex One server with the Apex Central console, connected to Trend Micro’s Smart Protection Network.</a:t>
             </a:r>
             <a:endParaRPr lang="en-US" dirty="0"/>
           </a:p>
@@ -3197,7 +3197,7 @@
                 <a:ea typeface="Arial" pitchFamily="34" charset="-122"/>
                 <a:cs typeface="Arial" pitchFamily="34" charset="-120"/>
               </a:rPr>
-              <a:t>Stopping Ransomware and Locking Down POS Systems</a:t>
+              <a:t>Ransomware Protection and System Lockdown</a:t>
             </a:r>
             <a:endParaRPr lang="en-US" sz="2800" dirty="0"/>
           </a:p>
@@ -3897,7 +3897,7 @@
                 <a:ea typeface="Calibri" pitchFamily="34" charset="-122"/>
                 <a:cs typeface="Calibri" pitchFamily="34" charset="-120"/>
               </a:rPr>
-              <a:t>Ideal for POS terminals, kiosks and front-desk systems that should never change.</a:t>
+              <a:t>Ideal for front-desk, PMS and other systems that should never change.</a:t>
             </a:r>
             <a:endParaRPr lang="en-US" sz="1200" dirty="0"/>
           </a:p>
@@ -5383,11 +5383,11 @@
             </a:avLst>
           </a:prstGeom>
           <a:solidFill>
-            <a:srgbClr val="F4F5F7"/>
+            <a:srgbClr val="FFFFFF"/>
           </a:solidFill>
           <a:ln w="9525">
             <a:solidFill>
-              <a:srgbClr val="DEE1E5"/>
+              <a:srgbClr val="BFE4E8"/>
             </a:solidFill>
             <a:prstDash val="solid"/>
           </a:ln>
@@ -5408,11 +5408,11 @@
             <a:avLst/>
           </a:prstGeom>
           <a:solidFill>
-            <a:srgbClr val="EAEEF3"/>
+            <a:srgbClr val="0F8B99"/>
           </a:solidFill>
           <a:ln w="12700">
             <a:solidFill>
-              <a:srgbClr val="EAEEF3"/>
+              <a:srgbClr val="0F8B99"/>
             </a:solidFill>
             <a:prstDash val="solid"/>
           </a:ln>
@@ -5469,7 +5469,7 @@
             <a:r>
               <a:rPr lang="en-US" sz="950" b="1" spc="120" kern="0" dirty="0">
                 <a:solidFill>
-                  <a:srgbClr val="5D6B7E"/>
+                  <a:srgbClr val="0F8B99"/>
                 </a:solidFill>
                 <a:latin typeface="Calibri" pitchFamily="34" charset="0"/>
                 <a:ea typeface="Calibri" pitchFamily="34" charset="-122"/>
@@ -8736,7 +8736,7 @@
                 <a:ea typeface="Calibri" pitchFamily="34" charset="-122"/>
                 <a:cs typeface="Calibri" pitchFamily="34" charset="-120"/>
               </a:rPr>
-              <a:t>POS &amp; SYSTEM LOCKDOWN</a:t>
+              <a:t>SYSTEM LOCKDOWN</a:t>
             </a:r>
             <a:endParaRPr lang="en-US" sz="950" dirty="0"/>
           </a:p>
@@ -8775,7 +8775,7 @@
                 <a:ea typeface="Calibri" pitchFamily="34" charset="-122"/>
                 <a:cs typeface="Calibri" pitchFamily="34" charset="-120"/>
               </a:rPr>
-              <a:t>Allows only approved applications on POS terminals and front-desk systems.</a:t>
+              <a:t>Allows only approved applications on front-desk and critical systems.</a:t>
             </a:r>
             <a:endParaRPr lang="en-US" sz="1100" dirty="0"/>
           </a:p>
@@ -11349,7 +11349,7 @@
                           <a:ea typeface="Calibri" pitchFamily="34" charset="-122"/>
                           <a:cs typeface="Calibri" pitchFamily="34" charset="-120"/>
                         </a:rPr>
-                        <a:t>POS terminals</a:t>
+                        <a:t>24/7 expert support</a:t>
                       </a:r>
                       <a:endParaRPr lang="en-US" sz="1150" dirty="0">
                         <a:latin typeface="Calibri" charset="0"/>
@@ -11417,7 +11417,7 @@
                           <a:ea typeface="Calibri" pitchFamily="34" charset="-122"/>
                           <a:cs typeface="Calibri" pitchFamily="34" charset="-120"/>
                         </a:rPr>
-                        <a:t>Scanned only</a:t>
+                        <a:t>Not available</a:t>
                       </a:r>
                       <a:endParaRPr lang="en-US" sz="1150" dirty="0">
                         <a:latin typeface="Calibri" charset="0"/>
@@ -11482,7 +11482,7 @@
                           <a:ea typeface="Calibri" pitchFamily="34" charset="-122"/>
                           <a:cs typeface="Calibri" pitchFamily="34" charset="-120"/>
                         </a:rPr>
-                        <a:t>Supported protection point</a:t>
+                        <a:t>SECUKOREA</a:t>
                       </a:r>
                       <a:pPr indent="0" marL="0">
                         <a:buNone/>
@@ -11496,7 +11496,7 @@
                           <a:ea typeface="Calibri" pitchFamily="34" charset="-122"/>
                           <a:cs typeface="Calibri" pitchFamily="34" charset="-120"/>
                         </a:rPr>
-                        <a:t>  — lockdown to approved apps</a:t>
+                        <a:t>  — 24/7 technical support and a dedicated engineer</a:t>
                       </a:r>
                       <a:endParaRPr lang="en-US" sz="1150" dirty="0">
                         <a:latin typeface="Calibri" charset="0"/>
@@ -14672,7 +14672,7 @@
                 <a:ea typeface="Calibri" pitchFamily="34" charset="-122"/>
                 <a:cs typeface="Calibri" pitchFamily="34" charset="-120"/>
               </a:rPr>
-              <a:t>POS terminals</a:t>
+              <a:t>Shared &amp; guest-service PCs</a:t>
             </a:r>
             <a:endParaRPr lang="en-US" sz="1050" dirty="0"/>
           </a:p>
@@ -15887,7 +15887,7 @@
                 <a:ea typeface="Calibri" pitchFamily="34" charset="-122"/>
                 <a:cs typeface="Calibri" pitchFamily="34" charset="-120"/>
               </a:rPr>
-              <a:t>Legacy and POS systems hard to protect</a:t>
+              <a:t>Legacy systems hard to protect</a:t>
             </a:r>
             <a:endParaRPr lang="en-US" sz="1250" dirty="0"/>
           </a:p>
@@ -16128,7 +16128,7 @@
                 <a:ea typeface="Calibri" pitchFamily="34" charset="-122"/>
                 <a:cs typeface="Calibri" pitchFamily="34" charset="-120"/>
               </a:rPr>
-              <a:t>WITH TREND MICRO APEX ONE</a:t>
+              <a:t>TOMORROW  ·  TREND MICRO APEX ONE</a:t>
             </a:r>
             <a:endParaRPr lang="en-US" sz="1100" dirty="0"/>
           </a:p>
@@ -16317,7 +16317,7 @@
                 <a:ea typeface="Calibri" pitchFamily="34" charset="-122"/>
                 <a:cs typeface="Calibri" pitchFamily="34" charset="-120"/>
               </a:rPr>
-              <a:t>POS and legacy systems locked down</a:t>
+              <a:t>Legacy systems shielded and locked down</a:t>
             </a:r>
             <a:endParaRPr lang="en-US" sz="1250" dirty="0"/>
           </a:p>
@@ -17902,7 +17902,7 @@
                 <a:ea typeface="Calibri" pitchFamily="34" charset="-122"/>
                 <a:cs typeface="Calibri" pitchFamily="34" charset="-120"/>
               </a:rPr>
-              <a:t>One on-premises agent combines anti-malware, ransomware rollback, virtual patching and app control — POS included.</a:t>
+              <a:t>One on-premises agent combines anti-malware, ransomware rollback, virtual patching and application control.</a:t>
             </a:r>
             <a:endParaRPr lang="en-US" sz="1200" dirty="0"/>
           </a:p>
@@ -19660,7 +19660,7 @@
                 <a:ea typeface="Arial" pitchFamily="34" charset="-122"/>
                 <a:cs typeface="Arial" pitchFamily="34" charset="-120"/>
               </a:rPr>
-              <a:t>One engineer who knows your systems</a:t>
+              <a:t>Your Own Dedicated Engineer</a:t>
             </a:r>
             <a:endParaRPr lang="en-US" sz="2000" dirty="0"/>
           </a:p>
@@ -19699,7 +19699,7 @@
                 <a:ea typeface="Calibri" pitchFamily="34" charset="-122"/>
                 <a:cs typeface="Calibri" pitchFamily="34" charset="-120"/>
               </a:rPr>
-              <a:t>A named SECUKOREA engineer is assigned to The Westin Resort Guam.</a:t>
+              <a:t>SECUKOREA will assign a dedicated engineer to The Westin Resort Guam.</a:t>
             </a:r>
             <a:endParaRPr lang="en-US" sz="1200" dirty="0"/>
           </a:p>
@@ -19787,7 +19787,7 @@
                 <a:ea typeface="Calibri" pitchFamily="34" charset="-122"/>
                 <a:cs typeface="Calibri" pitchFamily="34" charset="-120"/>
               </a:rPr>
-              <a:t>Installation, policy setup and tuning</a:t>
+              <a:t>Single point of contact for day-to-day requests</a:t>
             </a:r>
             <a:endParaRPr lang="en-US" sz="1250" dirty="0"/>
           </a:p>
@@ -19875,7 +19875,7 @@
                 <a:ea typeface="Calibri" pitchFamily="34" charset="-122"/>
                 <a:cs typeface="Calibri" pitchFamily="34" charset="-120"/>
               </a:rPr>
-              <a:t>Pattern, agent and server updates</a:t>
+              <a:t>Fast escalation to Trend Micro when needed</a:t>
             </a:r>
             <a:endParaRPr lang="en-US" sz="1250" dirty="0"/>
           </a:p>
@@ -19963,7 +19963,7 @@
                 <a:ea typeface="Calibri" pitchFamily="34" charset="-122"/>
                 <a:cs typeface="Calibri" pitchFamily="34" charset="-120"/>
               </a:rPr>
-              <a:t>Single point of contact for day-to-day requests</a:t>
+              <a:t>Committed to stable, uninterrupted security</a:t>
             </a:r>
             <a:endParaRPr lang="en-US" sz="1250" dirty="0"/>
           </a:p>
@@ -20051,7 +20051,7 @@
                 <a:ea typeface="Calibri" pitchFamily="34" charset="-122"/>
                 <a:cs typeface="Calibri" pitchFamily="34" charset="-120"/>
               </a:rPr>
-              <a:t>Regular health checks and status reports</a:t>
+              <a:t>Complete peace of mind for the resort</a:t>
             </a:r>
             <a:endParaRPr lang="en-US" sz="1250" dirty="0"/>
           </a:p>
@@ -20139,7 +20139,7 @@
                 <a:ea typeface="Calibri" pitchFamily="34" charset="-122"/>
                 <a:cs typeface="Calibri" pitchFamily="34" charset="-120"/>
               </a:rPr>
-              <a:t>Coordination with Trend Micro when needed</a:t>
+              <a:t>A long-term partner in keeping guests safe</a:t>
             </a:r>
             <a:endParaRPr lang="en-US" sz="1250" dirty="0"/>
           </a:p>
@@ -20805,7 +20805,7 @@
                 <a:ea typeface="Arial" pitchFamily="34" charset="-122"/>
                 <a:cs typeface="Arial" pitchFamily="34" charset="-120"/>
               </a:rPr>
-              <a:t>POS and Legacy Systems</a:t>
+              <a:t>Legacy Systems</a:t>
             </a:r>
             <a:endParaRPr lang="en-US" sz="1500" dirty="0"/>
           </a:p>
@@ -20844,7 +20844,7 @@
                 <a:ea typeface="Calibri" pitchFamily="34" charset="-122"/>
                 <a:cs typeface="Calibri" pitchFamily="34" charset="-120"/>
               </a:rPr>
-              <a:t>Payment terminals and older Windows systems are hard to patch quickly — and card data makes them a prime target.</a:t>
+              <a:t>Older Windows systems and hotel applications are hard to patch quickly — leaving known weaknesses open to attack.</a:t>
             </a:r>
             <a:endParaRPr lang="en-US" sz="1200" dirty="0"/>
           </a:p>
@@ -21099,7 +21099,7 @@
                 <a:ea typeface="Calibri" pitchFamily="34" charset="-122"/>
                 <a:cs typeface="Calibri" pitchFamily="34" charset="-120"/>
               </a:rPr>
-              <a:t>POS and fixed-function systems locked down</a:t>
+              <a:t>Legacy and critical systems locked down</a:t>
             </a:r>
             <a:endParaRPr lang="en-US" sz="1300" dirty="0"/>
           </a:p>
@@ -26611,13 +26611,13 @@
             <a:r>
               <a:rPr lang="en-US" sz="1150" b="1" dirty="0">
                 <a:solidFill>
-                  <a:srgbClr val="0F8B99"/>
+                  <a:srgbClr val="0E2233"/>
                 </a:solidFill>
                 <a:latin typeface="Calibri" pitchFamily="34" charset="0"/>
                 <a:ea typeface="Calibri" pitchFamily="34" charset="-122"/>
                 <a:cs typeface="Calibri" pitchFamily="34" charset="-120"/>
               </a:rPr>
-              <a:t>POS &amp; ATM endpoints</a:t>
+              <a:t>Laptops</a:t>
             </a:r>
             <a:endParaRPr lang="en-US" sz="1150" dirty="0"/>
           </a:p>
@@ -30698,7 +30698,7 @@
                 <a:ea typeface="Calibri" pitchFamily="34" charset="-122"/>
                 <a:cs typeface="Calibri" pitchFamily="34" charset="-120"/>
               </a:rPr>
-              <a:t>Extends the safe life of older PMS, POS and back-office systems</a:t>
+              <a:t>Extends the safe life of older PMS and back-office systems</a:t>
             </a:r>
             <a:endParaRPr lang="en-US" sz="1200" dirty="0"/>
           </a:p>

</xml_diff>